<commit_message>
modifier rapport et presen
</commit_message>
<xml_diff>
--- a/Rapport-Presentation/PFE Presentation.pptx
+++ b/Rapport-Presentation/PFE Presentation.pptx
@@ -26,7 +26,7 @@
   <p:notesSz cx="6858000" cy="9144000"/>
   <p:embeddedFontLst>
     <p:embeddedFont>
-      <p:font typeface="Playfair Display" panose="00000500000000000000" pitchFamily="2" charset="0"/>
+      <p:font typeface="Public Sans Bold" panose="020B0604020202020204" charset="0"/>
       <p:regular r:id="rId14"/>
     </p:embeddedFont>
     <p:embeddedFont>
@@ -34,8 +34,15 @@
       <p:regular r:id="rId15"/>
     </p:embeddedFont>
     <p:embeddedFont>
-      <p:font typeface="Public Sans Bold" panose="020B0604020202020204" charset="0"/>
+      <p:font typeface="Playfair Display" panose="020B0604020202020204" charset="0"/>
       <p:regular r:id="rId16"/>
+    </p:embeddedFont>
+    <p:embeddedFont>
+      <p:font typeface="Calibri" panose="020F0502020204030204" pitchFamily="34" charset="0"/>
+      <p:regular r:id="rId17"/>
+      <p:bold r:id="rId18"/>
+      <p:italic r:id="rId19"/>
+      <p:boldItalic r:id="rId20"/>
     </p:embeddedFont>
   </p:embeddedFontLst>
   <p:defaultTextStyle>
@@ -246,7 +253,7 @@
           <a:p>
             <a:fld id="{2BC6D4CA-2FE8-4A0B-BDD7-5D9EBA72A6A1}" type="datetimeFigureOut">
               <a:rPr lang="en-US" smtClean="0"/>
-              <a:t>3/30/2024</a:t>
+              <a:t>3/31/2024</a:t>
             </a:fld>
             <a:endParaRPr lang="en-US"/>
           </a:p>
@@ -324,7 +331,7 @@
           <a:p>
             <a:fld id="{B5DE1102-BF0F-4371-BB7A-2B75EA2DF77F}" type="slidenum">
               <a:rPr lang="en-US" smtClean="0"/>
-              <a:t>‹#›</a:t>
+              <a:t>‹N°›</a:t>
             </a:fld>
             <a:endParaRPr lang="en-US"/>
           </a:p>
@@ -423,7 +430,7 @@
           <a:p>
             <a:fld id="{70BA7285-3CB5-4847-A7CC-E502C46578E6}" type="datetimeFigureOut">
               <a:rPr lang="en-US" smtClean="0"/>
-              <a:t>3/30/2024</a:t>
+              <a:t>3/31/2024</a:t>
             </a:fld>
             <a:endParaRPr lang="en-US"/>
           </a:p>
@@ -581,7 +588,7 @@
           <a:p>
             <a:fld id="{DBB5A8C6-91A8-440C-BDB0-CC60F0A0157B}" type="slidenum">
               <a:rPr lang="en-US" smtClean="0"/>
-              <a:t>‹#›</a:t>
+              <a:t>‹N°›</a:t>
             </a:fld>
             <a:endParaRPr lang="en-US"/>
           </a:p>
@@ -869,7 +876,7 @@
           <a:p>
             <a:fld id="{63D53160-93FF-4D48-AF47-49B21CD2A91F}" type="datetime1">
               <a:rPr lang="en-US" smtClean="0"/>
-              <a:t>3/30/2024</a:t>
+              <a:t>3/31/2024</a:t>
             </a:fld>
             <a:endParaRPr lang="en-US"/>
           </a:p>
@@ -912,7 +919,7 @@
             <a:fld id="{B6F15528-21DE-4FAA-801E-634DDDAF4B2B}" type="slidenum">
               <a:rPr lang="en-US" smtClean="0"/>
               <a:pPr/>
-              <a:t>‹#›</a:t>
+              <a:t>‹N°›</a:t>
             </a:fld>
             <a:endParaRPr lang="en-US"/>
           </a:p>
@@ -1033,7 +1040,7 @@
           <a:p>
             <a:fld id="{D6F16AFA-65F9-43AD-99CD-FB0A7FBFA006}" type="datetime1">
               <a:rPr lang="en-US" smtClean="0"/>
-              <a:t>3/30/2024</a:t>
+              <a:t>3/31/2024</a:t>
             </a:fld>
             <a:endParaRPr lang="en-US"/>
           </a:p>
@@ -1076,7 +1083,7 @@
             <a:fld id="{B6F15528-21DE-4FAA-801E-634DDDAF4B2B}" type="slidenum">
               <a:rPr lang="en-US" smtClean="0"/>
               <a:pPr/>
-              <a:t>‹#›</a:t>
+              <a:t>‹N°›</a:t>
             </a:fld>
             <a:endParaRPr lang="en-US"/>
           </a:p>
@@ -1207,7 +1214,7 @@
           <a:p>
             <a:fld id="{94806966-C799-4A16-9707-536E850AFA6E}" type="datetime1">
               <a:rPr lang="en-US" smtClean="0"/>
-              <a:t>3/30/2024</a:t>
+              <a:t>3/31/2024</a:t>
             </a:fld>
             <a:endParaRPr lang="en-US"/>
           </a:p>
@@ -1250,7 +1257,7 @@
             <a:fld id="{B6F15528-21DE-4FAA-801E-634DDDAF4B2B}" type="slidenum">
               <a:rPr lang="en-US" smtClean="0"/>
               <a:pPr/>
-              <a:t>‹#›</a:t>
+              <a:t>‹N°›</a:t>
             </a:fld>
             <a:endParaRPr lang="en-US"/>
           </a:p>
@@ -1371,7 +1378,7 @@
           <a:p>
             <a:fld id="{94D6CA6D-956F-4323-A563-4E33502A6153}" type="datetime1">
               <a:rPr lang="en-US" smtClean="0"/>
-              <a:t>3/30/2024</a:t>
+              <a:t>3/31/2024</a:t>
             </a:fld>
             <a:endParaRPr lang="en-US"/>
           </a:p>
@@ -1414,7 +1421,7 @@
             <a:fld id="{B6F15528-21DE-4FAA-801E-634DDDAF4B2B}" type="slidenum">
               <a:rPr lang="en-US" smtClean="0"/>
               <a:pPr/>
-              <a:t>‹#›</a:t>
+              <a:t>‹N°›</a:t>
             </a:fld>
             <a:endParaRPr lang="en-US"/>
           </a:p>
@@ -1612,7 +1619,7 @@
           <a:p>
             <a:fld id="{A9EF6C37-C98A-4714-9044-10FAA24FBE3E}" type="datetime1">
               <a:rPr lang="en-US" smtClean="0"/>
-              <a:t>3/30/2024</a:t>
+              <a:t>3/31/2024</a:t>
             </a:fld>
             <a:endParaRPr lang="en-US"/>
           </a:p>
@@ -1655,7 +1662,7 @@
             <a:fld id="{B6F15528-21DE-4FAA-801E-634DDDAF4B2B}" type="slidenum">
               <a:rPr lang="en-US" smtClean="0"/>
               <a:pPr/>
-              <a:t>‹#›</a:t>
+              <a:t>‹N°›</a:t>
             </a:fld>
             <a:endParaRPr lang="en-US"/>
           </a:p>
@@ -1893,7 +1900,7 @@
           <a:p>
             <a:fld id="{71D640DE-BC91-415A-82DA-4ACB29742187}" type="datetime1">
               <a:rPr lang="en-US" smtClean="0"/>
-              <a:t>3/30/2024</a:t>
+              <a:t>3/31/2024</a:t>
             </a:fld>
             <a:endParaRPr lang="en-US"/>
           </a:p>
@@ -1936,7 +1943,7 @@
             <a:fld id="{B6F15528-21DE-4FAA-801E-634DDDAF4B2B}" type="slidenum">
               <a:rPr lang="en-US" smtClean="0"/>
               <a:pPr/>
-              <a:t>‹#›</a:t>
+              <a:t>‹N°›</a:t>
             </a:fld>
             <a:endParaRPr lang="en-US"/>
           </a:p>
@@ -2308,7 +2315,7 @@
           <a:p>
             <a:fld id="{64830954-33A7-409D-AE47-57600DD11109}" type="datetime1">
               <a:rPr lang="en-US" smtClean="0"/>
-              <a:t>3/30/2024</a:t>
+              <a:t>3/31/2024</a:t>
             </a:fld>
             <a:endParaRPr lang="en-US"/>
           </a:p>
@@ -2351,7 +2358,7 @@
             <a:fld id="{B6F15528-21DE-4FAA-801E-634DDDAF4B2B}" type="slidenum">
               <a:rPr lang="en-US" smtClean="0"/>
               <a:pPr/>
-              <a:t>‹#›</a:t>
+              <a:t>‹N°›</a:t>
             </a:fld>
             <a:endParaRPr lang="en-US"/>
           </a:p>
@@ -2421,7 +2428,7 @@
           <a:p>
             <a:fld id="{AC34727F-E8D9-405D-8CA4-43A771E46DEF}" type="datetime1">
               <a:rPr lang="en-US" smtClean="0"/>
-              <a:t>3/30/2024</a:t>
+              <a:t>3/31/2024</a:t>
             </a:fld>
             <a:endParaRPr lang="en-US"/>
           </a:p>
@@ -2464,7 +2471,7 @@
             <a:fld id="{B6F15528-21DE-4FAA-801E-634DDDAF4B2B}" type="slidenum">
               <a:rPr lang="en-US" smtClean="0"/>
               <a:pPr/>
-              <a:t>‹#›</a:t>
+              <a:t>‹N°›</a:t>
             </a:fld>
             <a:endParaRPr lang="en-US"/>
           </a:p>
@@ -2512,7 +2519,7 @@
           <a:p>
             <a:fld id="{4758CBDB-2B1E-40D5-A25F-74843C2C24F6}" type="datetime1">
               <a:rPr lang="en-US" smtClean="0"/>
-              <a:t>3/30/2024</a:t>
+              <a:t>3/31/2024</a:t>
             </a:fld>
             <a:endParaRPr lang="en-US"/>
           </a:p>
@@ -2564,7 +2571,7 @@
             <a:fld id="{B6F15528-21DE-4FAA-801E-634DDDAF4B2B}" type="slidenum">
               <a:rPr lang="en-US" smtClean="0"/>
               <a:pPr/>
-              <a:t>‹#›</a:t>
+              <a:t>‹N°›</a:t>
             </a:fld>
             <a:endParaRPr lang="en-US" dirty="0"/>
           </a:p>
@@ -2792,7 +2799,7 @@
           <a:p>
             <a:fld id="{6AD461B2-27BC-481A-98E0-F76C65EC3E83}" type="datetime1">
               <a:rPr lang="en-US" smtClean="0"/>
-              <a:t>3/30/2024</a:t>
+              <a:t>3/31/2024</a:t>
             </a:fld>
             <a:endParaRPr lang="en-US"/>
           </a:p>
@@ -2835,7 +2842,7 @@
             <a:fld id="{B6F15528-21DE-4FAA-801E-634DDDAF4B2B}" type="slidenum">
               <a:rPr lang="en-US" smtClean="0"/>
               <a:pPr/>
-              <a:t>‹#›</a:t>
+              <a:t>‹N°›</a:t>
             </a:fld>
             <a:endParaRPr lang="en-US"/>
           </a:p>
@@ -3040,7 +3047,7 @@
           <a:p>
             <a:fld id="{962D466E-3A1E-44CF-826F-F689C7096DBB}" type="datetime1">
               <a:rPr lang="en-US" smtClean="0"/>
-              <a:t>3/30/2024</a:t>
+              <a:t>3/31/2024</a:t>
             </a:fld>
             <a:endParaRPr lang="en-US"/>
           </a:p>
@@ -3083,7 +3090,7 @@
             <a:fld id="{B6F15528-21DE-4FAA-801E-634DDDAF4B2B}" type="slidenum">
               <a:rPr lang="en-US" smtClean="0"/>
               <a:pPr/>
-              <a:t>‹#›</a:t>
+              <a:t>‹N°›</a:t>
             </a:fld>
             <a:endParaRPr lang="en-US"/>
           </a:p>
@@ -3247,7 +3254,7 @@
           <a:p>
             <a:fld id="{EC5B68BF-B080-4206-BC3B-686C4086DEF1}" type="datetime1">
               <a:rPr lang="en-US" smtClean="0"/>
-              <a:t>3/30/2024</a:t>
+              <a:t>3/31/2024</a:t>
             </a:fld>
             <a:endParaRPr lang="en-US"/>
           </a:p>
@@ -3327,7 +3334,7 @@
             <a:fld id="{B6F15528-21DE-4FAA-801E-634DDDAF4B2B}" type="slidenum">
               <a:rPr lang="en-US" smtClean="0"/>
               <a:pPr/>
-              <a:t>‹#›</a:t>
+              <a:t>‹N°›</a:t>
             </a:fld>
             <a:endParaRPr lang="en-US" dirty="0"/>
           </a:p>
@@ -3682,7 +3689,7 @@
               </a:spcBef>
             </a:pPr>
             <a:r>
-              <a:rPr lang="en-US" sz="5400" dirty="0">
+              <a:rPr lang="en-US" sz="4800" dirty="0">
                 <a:solidFill>
                   <a:schemeClr val="tx1">
                     <a:lumMod val="65000"/>
@@ -3705,7 +3712,7 @@
         <p:spPr>
           <a:xfrm>
             <a:off x="850974" y="3637740"/>
-            <a:ext cx="16408332" cy="1810560"/>
+            <a:ext cx="16408332" cy="2708434"/>
           </a:xfrm>
           <a:prstGeom prst="rect">
             <a:avLst/>
@@ -3717,20 +3724,22 @@
           </a:bodyPr>
           <a:lstStyle/>
           <a:p>
-            <a:pPr algn="ctr">
-              <a:lnSpc>
-                <a:spcPts val="15250"/>
-              </a:lnSpc>
-            </a:pPr>
-            <a:r>
-              <a:rPr lang="en-US" sz="11700" spc="83" dirty="0">
+            <a:pPr algn="ctr"/>
+            <a:r>
+              <a:rPr lang="en-US" sz="8800" spc="83" dirty="0" smtClean="0">
                 <a:solidFill>
                   <a:srgbClr val="2B2C30"/>
                 </a:solidFill>
                 <a:latin typeface="Playfair Display"/>
               </a:rPr>
-              <a:t>E-Learning Platform</a:t>
-            </a:r>
+              <a:t>E-Learning Platform for University Teaching</a:t>
+            </a:r>
+            <a:endParaRPr lang="en-US" sz="8800" spc="83" dirty="0">
+              <a:solidFill>
+                <a:srgbClr val="2B2C30"/>
+              </a:solidFill>
+              <a:latin typeface="Playfair Display"/>
+            </a:endParaRPr>
           </a:p>
         </p:txBody>
       </p:sp>
@@ -3742,7 +3751,7 @@
         </p:nvSpPr>
         <p:spPr>
           <a:xfrm>
-            <a:off x="2653165" y="6438900"/>
+            <a:off x="2653165" y="7066703"/>
             <a:ext cx="7862435" cy="1643207"/>
           </a:xfrm>
           <a:prstGeom prst="rect">
@@ -3858,7 +3867,7 @@
         </p:nvSpPr>
         <p:spPr>
           <a:xfrm>
-            <a:off x="11035165" y="6438900"/>
+            <a:off x="11035165" y="7107644"/>
             <a:ext cx="7862435" cy="1112292"/>
           </a:xfrm>
           <a:prstGeom prst="rect">
@@ -3951,7 +3960,7 @@
         <p:spPr>
           <a:xfrm>
             <a:off x="7188240" y="1586925"/>
-            <a:ext cx="3733800" cy="584775"/>
+            <a:ext cx="4165560" cy="584775"/>
           </a:xfrm>
           <a:prstGeom prst="rect">
             <a:avLst/>
@@ -3986,6 +3995,13 @@
   <p:clrMapOvr>
     <a:masterClrMapping/>
   </p:clrMapOvr>
+  <p:timing>
+    <p:tnLst>
+      <p:par>
+        <p:cTn id="1" dur="indefinite" restart="never" nodeType="tmRoot"/>
+      </p:par>
+    </p:tnLst>
+  </p:timing>
 </p:sld>
 </file>
 
@@ -4111,6 +4127,13 @@
   <p:clrMapOvr>
     <a:masterClrMapping/>
   </p:clrMapOvr>
+  <p:timing>
+    <p:tnLst>
+      <p:par>
+        <p:cTn id="1" dur="indefinite" restart="never" nodeType="tmRoot"/>
+      </p:par>
+    </p:tnLst>
+  </p:timing>
 </p:sld>
 </file>
 
@@ -5082,6 +5105,13 @@
   <p:clrMapOvr>
     <a:masterClrMapping/>
   </p:clrMapOvr>
+  <p:timing>
+    <p:tnLst>
+      <p:par>
+        <p:cTn id="1" dur="indefinite" restart="never" nodeType="tmRoot"/>
+      </p:par>
+    </p:tnLst>
+  </p:timing>
 </p:sld>
 </file>
 
@@ -5189,6 +5219,13 @@
   <p:clrMapOvr>
     <a:masterClrMapping/>
   </p:clrMapOvr>
+  <p:timing>
+    <p:tnLst>
+      <p:par>
+        <p:cTn id="1" dur="indefinite" restart="never" nodeType="tmRoot"/>
+      </p:par>
+    </p:tnLst>
+  </p:timing>
 </p:sld>
 </file>
 
@@ -5438,6 +5475,13 @@
   <p:clrMapOvr>
     <a:masterClrMapping/>
   </p:clrMapOvr>
+  <p:timing>
+    <p:tnLst>
+      <p:par>
+        <p:cTn id="1" dur="indefinite" restart="never" nodeType="tmRoot"/>
+      </p:par>
+    </p:tnLst>
+  </p:timing>
 </p:sld>
 </file>
 
@@ -6993,6 +7037,13 @@
   <p:clrMapOvr>
     <a:masterClrMapping/>
   </p:clrMapOvr>
+  <p:timing>
+    <p:tnLst>
+      <p:par>
+        <p:cTn id="1" dur="indefinite" restart="never" nodeType="tmRoot"/>
+      </p:par>
+    </p:tnLst>
+  </p:timing>
 </p:sld>
 </file>
 
@@ -7105,6 +7156,13 @@
   <p:clrMapOvr>
     <a:masterClrMapping/>
   </p:clrMapOvr>
+  <p:timing>
+    <p:tnLst>
+      <p:par>
+        <p:cTn id="1" dur="indefinite" restart="never" nodeType="tmRoot"/>
+      </p:par>
+    </p:tnLst>
+  </p:timing>
 </p:sld>
 </file>
 
@@ -7293,6 +7351,13 @@
   <p:clrMapOvr>
     <a:masterClrMapping/>
   </p:clrMapOvr>
+  <p:timing>
+    <p:tnLst>
+      <p:par>
+        <p:cTn id="1" dur="indefinite" restart="never" nodeType="tmRoot"/>
+      </p:par>
+    </p:tnLst>
+  </p:timing>
 </p:sld>
 </file>
 
@@ -7405,6 +7470,13 @@
   <p:clrMapOvr>
     <a:masterClrMapping/>
   </p:clrMapOvr>
+  <p:timing>
+    <p:tnLst>
+      <p:par>
+        <p:cTn id="1" dur="indefinite" restart="never" nodeType="tmRoot"/>
+      </p:par>
+    </p:tnLst>
+  </p:timing>
 </p:sld>
 </file>
 
@@ -7517,6 +7589,13 @@
   <p:clrMapOvr>
     <a:masterClrMapping/>
   </p:clrMapOvr>
+  <p:timing>
+    <p:tnLst>
+      <p:par>
+        <p:cTn id="1" dur="indefinite" restart="never" nodeType="tmRoot"/>
+      </p:par>
+    </p:tnLst>
+  </p:timing>
 </p:sld>
 </file>
 

</xml_diff>